<commit_message>
Run visual PPTX QA and fix presentation
</commit_message>
<xml_diff>
--- a/produksjon_farrisbrua/07_Presentasjon_B43_Farrisbrua.pptx
+++ b/produksjon_farrisbrua/07_Presentasjon_B43_Farrisbrua.pptx
@@ -1618,7 +1618,7 @@
                   <a:srgbClr val="1D252C"/>
                 </a:solidFill>
               </a:rPr>
-              <a:t>Realistisk spillovelse for 110-vaktlag</a:t>
+              <a:t>Realistisk spilløvelse for 110-vaktlag</a:t>
             </a:r>
             <a:endParaRPr lang="en-US" sz="1800" dirty="0"/>
           </a:p>
@@ -1909,7 +1909,7 @@
                   <a:srgbClr val="5F6B76"/>
                 </a:solidFill>
               </a:rPr>
-              <a:t>Scenarioet er ukjent for de ovende ved start. Bildet brukes forst i ettergjennomgang eller pa riktig tidspunkt i spillet.</a:t>
+              <a:t>Scenarioet er ukjent for de øvende ved start. Bildet brukes først i ettergjennomgang eller på riktig tidspunkt i spillet.</a:t>
             </a:r>
             <a:endParaRPr lang="en-US" sz="1050" dirty="0"/>
           </a:p>
@@ -1987,7 +1987,7 @@
                 <a:ea typeface="Arial" pitchFamily="34" charset="-122"/>
                 <a:cs typeface="Arial" pitchFamily="34" charset="-120"/>
               </a:rPr>
-              <a:t>OVELSE - fiktivt scenario</a:t>
+              <a:t>ØVELSE - fiktivt scenario</a:t>
             </a:r>
             <a:endParaRPr lang="en-US" sz="750" dirty="0"/>
           </a:p>
@@ -2086,7 +2086,7 @@
                   <a:srgbClr val="203864"/>
                 </a:solidFill>
               </a:rPr>
-              <a:t>For-brief: rammer for de ovende</a:t>
+              <a:t>Før-brief: rammer for de øvende</a:t>
             </a:r>
             <a:endParaRPr lang="en-US" sz="2500" dirty="0"/>
           </a:p>
@@ -2144,7 +2144,7 @@
                   <a:srgbClr val="1D252C"/>
                 </a:solidFill>
               </a:rPr>
-              <a:t>B43 er en fiktiv ovelsessentral i kontrollromsetting.</a:t>
+              <a:t>B43 er en fiktiv øvelsessentral i kontrollromsetting.</a:t>
             </a:r>
             <a:endParaRPr lang="en-US" sz="1500" dirty="0"/>
           </a:p>
@@ -2155,7 +2155,7 @@
                   <a:srgbClr val="1D252C"/>
                 </a:solidFill>
               </a:rPr>
-              <a:t>Ovelsen varer ca. 90 minutter og kjores som spillovelse.</a:t>
+              <a:t>Øvelsen varer ca. 90 minutter og kjøres som spilløvelse.</a:t>
             </a:r>
             <a:endParaRPr lang="en-US" sz="1500" dirty="0"/>
           </a:p>
@@ -2166,7 +2166,7 @@
                   <a:srgbClr val="1D252C"/>
                 </a:solidFill>
               </a:rPr>
-              <a:t>Systembruk/LEO evalueres bare der det er nodvendig for gjennomforingen.</a:t>
+              <a:t>Systembruk/LEO evalueres bare der det er nødvendig for gjennomføringen.</a:t>
             </a:r>
             <a:endParaRPr lang="en-US" sz="1500" dirty="0"/>
           </a:p>
@@ -2289,7 +2289,7 @@
                   <a:srgbClr val="203864"/>
                 </a:solidFill>
               </a:rPr>
-              <a:t>STOPP OVELSE B43</a:t>
+              <a:t>STOPP ØVELSE B43</a:t>
             </a:r>
             <a:endParaRPr lang="en-US" sz="2200" dirty="0"/>
           </a:p>
@@ -2327,7 +2327,7 @@
                   <a:srgbClr val="1D252C"/>
                 </a:solidFill>
               </a:rPr>
-              <a:t>Ved reell hendelse eller uklarhet stoppes ovelsen og ovingsleder avklarer videre handtering.</a:t>
+              <a:t>Ved reell hendelse eller uklarhet stoppes øvelsen og øvingsleder avklarer videre håndtering.</a:t>
             </a:r>
             <a:endParaRPr lang="en-US" sz="1200" dirty="0"/>
           </a:p>
@@ -2405,7 +2405,7 @@
                 <a:ea typeface="Arial" pitchFamily="34" charset="-122"/>
                 <a:cs typeface="Arial" pitchFamily="34" charset="-120"/>
               </a:rPr>
-              <a:t>OVELSE - fiktivt scenario</a:t>
+              <a:t>ØVELSE - fiktivt scenario</a:t>
             </a:r>
             <a:endParaRPr lang="en-US" sz="750" dirty="0"/>
           </a:p>
@@ -2504,7 +2504,7 @@
                   <a:srgbClr val="203864"/>
                 </a:solidFill>
               </a:rPr>
-              <a:t>Laringsmal for vaktlaget</a:t>
+              <a:t>Læringsmål for vaktlaget</a:t>
             </a:r>
             <a:endParaRPr lang="en-US" sz="2500" dirty="0"/>
           </a:p>
@@ -2626,7 +2626,7 @@
                   <a:srgbClr val="1D252C"/>
                 </a:solidFill>
               </a:rPr>
-              <a:t>Handtere forste nodmelding og utalarmering strukturert og tidsriktig.</a:t>
+              <a:t>Håndtere første nødmelding og utalarmering strukturert og tidsriktig.</a:t>
             </a:r>
             <a:endParaRPr lang="en-US" sz="1550" dirty="0"/>
           </a:p>
@@ -2725,7 +2725,7 @@
                   <a:srgbClr val="1D252C"/>
                 </a:solidFill>
               </a:rPr>
-              <a:t>Etablere og oppdatere felles situasjonsforstaelse mens ressurser er pa vei.</a:t>
+              <a:t>Etablere og oppdatere felles situasjonsforståelse mens ressurser er på vei.</a:t>
             </a:r>
             <a:endParaRPr lang="en-US" sz="1550" dirty="0"/>
           </a:p>
@@ -3022,7 +3022,7 @@
                   <a:srgbClr val="1D252C"/>
                 </a:solidFill>
               </a:rPr>
-              <a:t>Oppsummere status presist for ovelsen avsluttes.</a:t>
+              <a:t>Oppsummere status presist før øvelsen avsluttes.</a:t>
             </a:r>
             <a:endParaRPr lang="en-US" sz="1550" dirty="0"/>
           </a:p>
@@ -3100,7 +3100,7 @@
                 <a:ea typeface="Arial" pitchFamily="34" charset="-122"/>
                 <a:cs typeface="Arial" pitchFamily="34" charset="-120"/>
               </a:rPr>
-              <a:t>OVELSE - fiktivt scenario</a:t>
+              <a:t>ØVELSE - fiktivt scenario</a:t>
             </a:r>
             <a:endParaRPr lang="en-US" sz="750" dirty="0"/>
           </a:p>
@@ -3890,7 +3890,7 @@
                   <a:srgbClr val="5F6B76"/>
                 </a:solidFill>
               </a:rPr>
-              <a:t>Dette er ikke en patvunget fasit, men en struktur som gjor det mulig a lykkes i et kunstig ovingsmiljo.</a:t>
+              <a:t>Dette er ikke en påtvunget fasit, men en struktur som gjør det mulig å lykkes i et kunstig øvingsmiljø.</a:t>
             </a:r>
             <a:endParaRPr lang="en-US" sz="1200" dirty="0"/>
           </a:p>
@@ -3968,7 +3968,7 @@
                 <a:ea typeface="Arial" pitchFamily="34" charset="-122"/>
                 <a:cs typeface="Arial" pitchFamily="34" charset="-120"/>
               </a:rPr>
-              <a:t>OVELSE - fiktivt scenario</a:t>
+              <a:t>ØVELSE - fiktivt scenario</a:t>
             </a:r>
             <a:endParaRPr lang="en-US" sz="750" dirty="0"/>
           </a:p>
@@ -4136,7 +4136,7 @@
                   <a:srgbClr val="1D252C"/>
                 </a:solidFill>
               </a:rPr>
-              <a:t>Ikke legg inn farlig last, sabotasje, mange hardt skadde eller storre eskalering uten ovingsleder.</a:t>
+              <a:t>Ikke legg inn farlig last, sabotasje, mange hardt skadde eller større eskalering uten øvingsleder.</a:t>
             </a:r>
             <a:endParaRPr lang="en-US" sz="1450" dirty="0"/>
           </a:p>
@@ -4158,7 +4158,7 @@
                   <a:srgbClr val="1D252C"/>
                 </a:solidFill>
               </a:rPr>
-              <a:t>Forsvaret/militaer kolonne er kontekst, ikke hovedaktor.</a:t>
+              <a:t>Forsvaret/militær kolonne er kontekst, ikke hovedaktør.</a:t>
             </a:r>
             <a:endParaRPr lang="en-US" sz="1450" dirty="0"/>
           </a:p>
@@ -4169,7 +4169,7 @@
                   <a:srgbClr val="1D252C"/>
                 </a:solidFill>
               </a:rPr>
-              <a:t>Dersom teknikk svikter, gis innspillet muntlig av ovingsleder.</a:t>
+              <a:t>Dersom teknikk svikter, gis innspillet muntlig av øvingsleder.</a:t>
             </a:r>
             <a:endParaRPr lang="en-US" sz="1450" dirty="0"/>
           </a:p>
@@ -4229,7 +4229,7 @@
                   <a:srgbClr val="5F6B76"/>
                 </a:solidFill>
               </a:rPr>
-              <a:t>Bildepakke brukes bare pa definert tidspunkt.</a:t>
+              <a:t>Bildepakke brukes bare på definert tidspunkt.</a:t>
             </a:r>
             <a:endParaRPr lang="en-US" sz="1250" dirty="0"/>
           </a:p>
@@ -4307,7 +4307,7 @@
                 <a:ea typeface="Arial" pitchFamily="34" charset="-122"/>
                 <a:cs typeface="Arial" pitchFamily="34" charset="-120"/>
               </a:rPr>
-              <a:t>OVELSE - fiktivt scenario</a:t>
+              <a:t>ØVELSE - fiktivt scenario</a:t>
             </a:r>
             <a:endParaRPr lang="en-US" sz="750" dirty="0"/>
           </a:p>
@@ -4406,7 +4406,7 @@
                   <a:srgbClr val="203864"/>
                 </a:solidFill>
               </a:rPr>
-              <a:t>Ettergjennomgang: faktisk ovelsesforlop</a:t>
+              <a:t>Ettergjennomgang: faktisk øvelsesforløp</a:t>
             </a:r>
             <a:endParaRPr lang="en-US" sz="2500" dirty="0"/>
           </a:p>
@@ -4468,17 +4468,19 @@
         </p:nvSpPr>
         <p:spPr>
           <a:xfrm>
-            <a:off x="795528" y="2084832"/>
-            <a:ext cx="1417320" cy="146304"/>
-          </a:xfrm>
-          <a:prstGeom prst="rect">
-            <a:avLst/>
-          </a:prstGeom>
-          <a:noFill/>
-          <a:ln/>
-        </p:spPr>
-        <p:txBody>
-          <a:bodyPr wrap="square" rtlCol="0" anchor="ctr"/>
+            <a:off x="1143000" y="2084832"/>
+            <a:ext cx="1188720" cy="146304"/>
+          </a:xfrm>
+          <a:prstGeom prst="rect">
+            <a:avLst/>
+          </a:prstGeom>
+          <a:noFill/>
+          <a:ln/>
+        </p:spPr>
+        <p:txBody>
+          <a:bodyPr wrap="square" rtlCol="0" anchor="ctr">
+            <a:normAutofit/>
+          </a:bodyPr>
           <a:lstStyle/>
           <a:p>
             <a:pPr indent="0" marL="0">
@@ -4504,8 +4506,8 @@
         </p:nvSpPr>
         <p:spPr>
           <a:xfrm>
-            <a:off x="795528" y="2331720"/>
-            <a:ext cx="1508760" cy="310896"/>
+            <a:off x="1143000" y="2304288"/>
+            <a:ext cx="1234440" cy="411480"/>
           </a:xfrm>
           <a:prstGeom prst="rect">
             <a:avLst/>
@@ -4581,17 +4583,19 @@
         </p:nvSpPr>
         <p:spPr>
           <a:xfrm>
-            <a:off x="3035808" y="2084832"/>
-            <a:ext cx="1417320" cy="146304"/>
-          </a:xfrm>
-          <a:prstGeom prst="rect">
-            <a:avLst/>
-          </a:prstGeom>
-          <a:noFill/>
-          <a:ln/>
-        </p:spPr>
-        <p:txBody>
-          <a:bodyPr wrap="square" rtlCol="0" anchor="ctr"/>
+            <a:off x="3383280" y="2084832"/>
+            <a:ext cx="1188720" cy="146304"/>
+          </a:xfrm>
+          <a:prstGeom prst="rect">
+            <a:avLst/>
+          </a:prstGeom>
+          <a:noFill/>
+          <a:ln/>
+        </p:spPr>
+        <p:txBody>
+          <a:bodyPr wrap="square" rtlCol="0" anchor="ctr">
+            <a:normAutofit/>
+          </a:bodyPr>
           <a:lstStyle/>
           <a:p>
             <a:pPr indent="0" marL="0">
@@ -4617,8 +4621,8 @@
         </p:nvSpPr>
         <p:spPr>
           <a:xfrm>
-            <a:off x="3035808" y="2331720"/>
-            <a:ext cx="1508760" cy="310896"/>
+            <a:off x="3383280" y="2304288"/>
+            <a:ext cx="1234440" cy="411480"/>
           </a:xfrm>
           <a:prstGeom prst="rect">
             <a:avLst/>
@@ -4694,44 +4698,8 @@
         </p:nvSpPr>
         <p:spPr>
           <a:xfrm>
-            <a:off x="5276088" y="2084832"/>
-            <a:ext cx="1417320" cy="146304"/>
-          </a:xfrm>
-          <a:prstGeom prst="rect">
-            <a:avLst/>
-          </a:prstGeom>
-          <a:noFill/>
-          <a:ln/>
-        </p:spPr>
-        <p:txBody>
-          <a:bodyPr wrap="square" rtlCol="0" anchor="ctr"/>
-          <a:lstStyle/>
-          <a:p>
-            <a:pPr indent="0" marL="0">
-              <a:buNone/>
-            </a:pPr>
-            <a:r>
-              <a:rPr lang="en-US" sz="1000" b="1" dirty="0">
-                <a:solidFill>
-                  <a:srgbClr val="FFFFFF"/>
-                </a:solidFill>
-              </a:rPr>
-              <a:t>22-35 min</a:t>
-            </a:r>
-            <a:endParaRPr lang="en-US" sz="1000" dirty="0"/>
-          </a:p>
-        </p:txBody>
-      </p:sp>
-      <p:sp>
-        <p:nvSpPr>
-          <p:cNvPr id="13" name="Text 11"/>
-          <p:cNvSpPr/>
-          <p:nvPr/>
-        </p:nvSpPr>
-        <p:spPr>
-          <a:xfrm>
-            <a:off x="5276088" y="2331720"/>
-            <a:ext cx="1508760" cy="310896"/>
+            <a:off x="5623560" y="2084832"/>
+            <a:ext cx="1188720" cy="146304"/>
           </a:xfrm>
           <a:prstGeom prst="rect">
             <a:avLst/>
@@ -4749,12 +4717,50 @@
               <a:buNone/>
             </a:pPr>
             <a:r>
+              <a:rPr lang="en-US" sz="1000" b="1" dirty="0">
+                <a:solidFill>
+                  <a:srgbClr val="FFFFFF"/>
+                </a:solidFill>
+              </a:rPr>
+              <a:t>22-35 min</a:t>
+            </a:r>
+            <a:endParaRPr lang="en-US" sz="1000" dirty="0"/>
+          </a:p>
+        </p:txBody>
+      </p:sp>
+      <p:sp>
+        <p:nvSpPr>
+          <p:cNvPr id="13" name="Text 11"/>
+          <p:cNvSpPr/>
+          <p:nvPr/>
+        </p:nvSpPr>
+        <p:spPr>
+          <a:xfrm>
+            <a:off x="5623560" y="2304288"/>
+            <a:ext cx="1234440" cy="411480"/>
+          </a:xfrm>
+          <a:prstGeom prst="rect">
+            <a:avLst/>
+          </a:prstGeom>
+          <a:noFill/>
+          <a:ln/>
+        </p:spPr>
+        <p:txBody>
+          <a:bodyPr wrap="square" rtlCol="0" anchor="ctr">
+            <a:normAutofit/>
+          </a:bodyPr>
+          <a:lstStyle/>
+          <a:p>
+            <a:pPr indent="0" marL="0">
+              <a:buNone/>
+            </a:pPr>
+            <a:r>
               <a:rPr lang="en-US" sz="1050" dirty="0">
                 <a:solidFill>
                   <a:srgbClr val="FFFFFF"/>
                 </a:solidFill>
               </a:rPr>
-              <a:t>Forste ressurs</a:t>
+              <a:t>Første ressurs</a:t>
             </a:r>
             <a:endParaRPr lang="en-US" sz="1050" dirty="0"/>
           </a:p>
@@ -4807,17 +4813,19 @@
         </p:nvSpPr>
         <p:spPr>
           <a:xfrm>
-            <a:off x="7516368" y="2084832"/>
-            <a:ext cx="1417320" cy="146304"/>
-          </a:xfrm>
-          <a:prstGeom prst="rect">
-            <a:avLst/>
-          </a:prstGeom>
-          <a:noFill/>
-          <a:ln/>
-        </p:spPr>
-        <p:txBody>
-          <a:bodyPr wrap="square" rtlCol="0" anchor="ctr"/>
+            <a:off x="7863840" y="2084832"/>
+            <a:ext cx="1188720" cy="146304"/>
+          </a:xfrm>
+          <a:prstGeom prst="rect">
+            <a:avLst/>
+          </a:prstGeom>
+          <a:noFill/>
+          <a:ln/>
+        </p:spPr>
+        <p:txBody>
+          <a:bodyPr wrap="square" rtlCol="0" anchor="ctr">
+            <a:normAutofit/>
+          </a:bodyPr>
           <a:lstStyle/>
           <a:p>
             <a:pPr indent="0" marL="0">
@@ -4843,8 +4851,8 @@
         </p:nvSpPr>
         <p:spPr>
           <a:xfrm>
-            <a:off x="7516368" y="2331720"/>
-            <a:ext cx="1508760" cy="310896"/>
+            <a:off x="7863840" y="2304288"/>
+            <a:ext cx="1234440" cy="411480"/>
           </a:xfrm>
           <a:prstGeom prst="rect">
             <a:avLst/>
@@ -4920,17 +4928,19 @@
         </p:nvSpPr>
         <p:spPr>
           <a:xfrm>
-            <a:off x="9756648" y="2084832"/>
-            <a:ext cx="1417320" cy="146304"/>
-          </a:xfrm>
-          <a:prstGeom prst="rect">
-            <a:avLst/>
-          </a:prstGeom>
-          <a:noFill/>
-          <a:ln/>
-        </p:spPr>
-        <p:txBody>
-          <a:bodyPr wrap="square" rtlCol="0" anchor="ctr"/>
+            <a:off x="10104120" y="2084832"/>
+            <a:ext cx="1188720" cy="146304"/>
+          </a:xfrm>
+          <a:prstGeom prst="rect">
+            <a:avLst/>
+          </a:prstGeom>
+          <a:noFill/>
+          <a:ln/>
+        </p:spPr>
+        <p:txBody>
+          <a:bodyPr wrap="square" rtlCol="0" anchor="ctr">
+            <a:normAutofit/>
+          </a:bodyPr>
           <a:lstStyle/>
           <a:p>
             <a:pPr indent="0" marL="0">
@@ -4956,8 +4966,8 @@
         </p:nvSpPr>
         <p:spPr>
           <a:xfrm>
-            <a:off x="9756648" y="2331720"/>
-            <a:ext cx="1508760" cy="310896"/>
+            <a:off x="10104120" y="2304288"/>
+            <a:ext cx="1234440" cy="411480"/>
           </a:xfrm>
           <a:prstGeom prst="rect">
             <a:avLst/>
@@ -5096,7 +5106,7 @@
                 <a:ea typeface="Arial" pitchFamily="34" charset="-122"/>
                 <a:cs typeface="Arial" pitchFamily="34" charset="-120"/>
               </a:rPr>
-              <a:t>OVELSE - fiktivt scenario</a:t>
+              <a:t>ØVELSE - fiktivt scenario</a:t>
             </a:r>
             <a:endParaRPr lang="en-US" sz="750" dirty="0"/>
           </a:p>
@@ -5624,7 +5634,7 @@
                   <a:srgbClr val="203864"/>
                 </a:solidFill>
               </a:rPr>
-              <a:t>Fokus pa hva og hvorfor, ikke hvem.</a:t>
+              <a:t>Fokus på hva og hvorfor, ikke hvem.</a:t>
             </a:r>
             <a:endParaRPr lang="en-US" sz="1500" dirty="0"/>
           </a:p>
@@ -5702,7 +5712,7 @@
                 <a:ea typeface="Arial" pitchFamily="34" charset="-122"/>
                 <a:cs typeface="Arial" pitchFamily="34" charset="-120"/>
               </a:rPr>
-              <a:t>OVELSE - fiktivt scenario</a:t>
+              <a:t>ØVELSE - fiktivt scenario</a:t>
             </a:r>
             <a:endParaRPr lang="en-US" sz="750" dirty="0"/>
           </a:p>
@@ -6418,7 +6428,7 @@
                 <a:ea typeface="Arial" pitchFamily="34" charset="-122"/>
                 <a:cs typeface="Arial" pitchFamily="34" charset="-120"/>
               </a:rPr>
-              <a:t>OVELSE - fiktivt scenario</a:t>
+              <a:t>ØVELSE - fiktivt scenario</a:t>
             </a:r>
             <a:endParaRPr lang="en-US" sz="750" dirty="0"/>
           </a:p>

</xml_diff>